<commit_message>
fix(deck): merge manually-wrapped sentences into single bullets
Slides 2, 9, and 11 had each hard-wrapped line rendering as its own
bullet marker instead of one bullet per complete sentence — python-pptx
already word-wraps within the text box, so the manual line breaks in
the source list were redundant and fragmented mid-sentence.
</commit_message>
<xml_diff>
--- a/BiasharaAssist_Capstone_Presentation.pptx
+++ b/BiasharaAssist_Capstone_Presentation.pptx
@@ -4352,7 +4352,7 @@
           <a:p>
             <a:pPr>
               <a:spcAft>
-                <a:spcPts val="1200"/>
+                <a:spcPts val="1600"/>
               </a:spcAft>
             </a:pPr>
             <a:r>
@@ -4368,7 +4368,7 @@
           <a:p>
             <a:pPr>
               <a:spcAft>
-                <a:spcPts val="1200"/>
+                <a:spcPts val="1600"/>
               </a:spcAft>
             </a:pPr>
             <a:r>
@@ -4378,13 +4378,13 @@
                 </a:solidFill>
                 <a:latin typeface="Calibri"/>
               </a:rPr>
-              <a:t>•  Covers the entire pipeline: setup, training, merge,</a:t>
+              <a:t>•  Covers the entire pipeline: setup, training, merge, inference, evaluation, through to pod termination</a:t>
             </a:r>
           </a:p>
           <a:p>
             <a:pPr>
               <a:spcAft>
-                <a:spcPts val="1200"/>
+                <a:spcPts val="1600"/>
               </a:spcAft>
             </a:pPr>
             <a:r>
@@ -4394,39 +4394,7 @@
                 </a:solidFill>
                 <a:latin typeface="Calibri"/>
               </a:rPr>
-              <a:t>•  inference, evaluation, through to pod termination</a:t>
-            </a:r>
-          </a:p>
-          <a:p>
-            <a:pPr>
-              <a:spcAft>
-                <a:spcPts val="1200"/>
-              </a:spcAft>
-            </a:pPr>
-            <a:r>
-              <a:rPr sz="1600" b="0">
-                <a:solidFill>
-                  <a:srgbClr val="1A1A1A"/>
-                </a:solidFill>
-                <a:latin typeface="Calibri"/>
-              </a:rPr>
-              <a:t>•  Not an estimate — pulled directly from RunPod's</a:t>
-            </a:r>
-          </a:p>
-          <a:p>
-            <a:pPr>
-              <a:spcAft>
-                <a:spcPts val="1200"/>
-              </a:spcAft>
-            </a:pPr>
-            <a:r>
-              <a:rPr sz="1600" b="0">
-                <a:solidFill>
-                  <a:srgbClr val="1A1A1A"/>
-                </a:solidFill>
-                <a:latin typeface="Calibri"/>
-              </a:rPr>
-              <a:t>•  billing export CSV, cited in memo.md</a:t>
+              <a:t>•  Not an estimate — pulled directly from RunPod's billing export CSV, cited in memo.md</a:t>
             </a:r>
           </a:p>
         </p:txBody>
@@ -5713,7 +5681,7 @@
           <a:p>
             <a:pPr>
               <a:spcAft>
-                <a:spcPts val="1200"/>
+                <a:spcPts val="1400"/>
               </a:spcAft>
             </a:pPr>
             <a:r>
@@ -5729,7 +5697,7 @@
           <a:p>
             <a:pPr>
               <a:spcAft>
-                <a:spcPts val="1200"/>
+                <a:spcPts val="1400"/>
               </a:spcAft>
             </a:pPr>
             <a:r>
@@ -5745,7 +5713,7 @@
           <a:p>
             <a:pPr>
               <a:spcAft>
-                <a:spcPts val="1200"/>
+                <a:spcPts val="1400"/>
               </a:spcAft>
             </a:pPr>
             <a:r>
@@ -5761,7 +5729,7 @@
           <a:p>
             <a:pPr>
               <a:spcAft>
-                <a:spcPts val="1200"/>
+                <a:spcPts val="1400"/>
               </a:spcAft>
             </a:pPr>
             <a:r>
@@ -5777,7 +5745,7 @@
           <a:p>
             <a:pPr>
               <a:spcAft>
-                <a:spcPts val="1200"/>
+                <a:spcPts val="1400"/>
               </a:spcAft>
             </a:pPr>
             <a:r>
@@ -5793,7 +5761,7 @@
           <a:p>
             <a:pPr>
               <a:spcAft>
-                <a:spcPts val="1200"/>
+                <a:spcPts val="1400"/>
               </a:spcAft>
             </a:pPr>
             <a:r>
@@ -5803,13 +5771,13 @@
                 </a:solidFill>
                 <a:latin typeface="Calibri"/>
               </a:rPr>
-              <a:t>•  General-purpose AI models don't know Kenya-specific rules,</a:t>
+              <a:t>•  General-purpose AI models don't know Kenya-specific rules, thresholds, or procedures — and can confidently make things up.</a:t>
             </a:r>
           </a:p>
           <a:p>
             <a:pPr>
               <a:spcAft>
-                <a:spcPts val="1200"/>
+                <a:spcPts val="1400"/>
               </a:spcAft>
             </a:pPr>
             <a:r>
@@ -5819,39 +5787,7 @@
                 </a:solidFill>
                 <a:latin typeface="Calibri"/>
               </a:rPr>
-              <a:t>•  thresholds, or procedures — and can confidently make things up.</a:t>
-            </a:r>
-          </a:p>
-          <a:p>
-            <a:pPr>
-              <a:spcAft>
-                <a:spcPts val="1200"/>
-              </a:spcAft>
-            </a:pPr>
-            <a:r>
-              <a:rPr sz="1700" b="0">
-                <a:solidFill>
-                  <a:srgbClr val="1A1A1A"/>
-                </a:solidFill>
-                <a:latin typeface="Calibri"/>
-              </a:rPr>
-              <a:t>•  A microfinance institution needs a non-advisory assistant that</a:t>
-            </a:r>
-          </a:p>
-          <a:p>
-            <a:pPr>
-              <a:spcAft>
-                <a:spcPts val="1200"/>
-              </a:spcAft>
-            </a:pPr>
-            <a:r>
-              <a:rPr sz="1700" b="0">
-                <a:solidFill>
-                  <a:srgbClr val="1A1A1A"/>
-                </a:solidFill>
-                <a:latin typeface="Calibri"/>
-              </a:rPr>
-              <a:t>•  sticks to verified facts, and never guarantees a loan outcome.</a:t>
+              <a:t>•  A microfinance institution needs a non-advisory assistant that sticks to verified facts, and never guarantees a loan outcome.</a:t>
             </a:r>
           </a:p>
         </p:txBody>
@@ -11909,7 +11845,7 @@
           <a:p>
             <a:pPr>
               <a:spcAft>
-                <a:spcPts val="1400"/>
+                <a:spcPts val="2200"/>
               </a:spcAft>
             </a:pPr>
             <a:r>
@@ -11919,13 +11855,13 @@
                 </a:solidFill>
                 <a:latin typeface="Calibri"/>
               </a:rPr>
-              <a:t>•  Every training response shares the same ~50-word disclaimer, which a lexical-overlap</a:t>
+              <a:t>•  Every training response shares the same ~50-word disclaimer, which a lexical-overlap metric (ROUGE-L) rewards heavily — regardless of whether the surrounding facts are correct.</a:t>
             </a:r>
           </a:p>
           <a:p>
             <a:pPr>
               <a:spcAft>
-                <a:spcPts val="1400"/>
+                <a:spcPts val="2200"/>
               </a:spcAft>
             </a:pPr>
             <a:r>
@@ -11935,13 +11871,13 @@
                 </a:solidFill>
                 <a:latin typeface="Calibri"/>
               </a:rPr>
-              <a:t>•  metric (ROUGE-L) rewards heavily — regardless of whether the surrounding facts are correct.</a:t>
+              <a:t>•  159 training examples spread across dozens of narrow sub-topics (Turnover Tax, Installment Tax, Hustler Fund terms, VAT thresholds...) — many sub-topics had only 1-2 supporting examples each.</a:t>
             </a:r>
           </a:p>
           <a:p>
             <a:pPr>
               <a:spcAft>
-                <a:spcPts val="1400"/>
+                <a:spcPts val="2200"/>
               </a:spcAft>
             </a:pPr>
             <a:r>
@@ -11951,13 +11887,13 @@
                 </a:solidFill>
                 <a:latin typeface="Calibri"/>
               </a:rPr>
-              <a:t>•  </a:t>
+              <a:t>•  Enough repetition to imprint fluent structure and tone. Not enough repetition to reliably fix exact numbers on narrow questions.</a:t>
             </a:r>
           </a:p>
           <a:p>
             <a:pPr>
               <a:spcAft>
-                <a:spcPts val="1400"/>
+                <a:spcPts val="2200"/>
               </a:spcAft>
             </a:pPr>
             <a:r>
@@ -11967,135 +11903,7 @@
                 </a:solidFill>
                 <a:latin typeface="Calibri"/>
               </a:rPr>
-              <a:t>•  159 training examples spread across dozens of narrow sub-topics (Turnover Tax, Installment</a:t>
-            </a:r>
-          </a:p>
-          <a:p>
-            <a:pPr>
-              <a:spcAft>
-                <a:spcPts val="1400"/>
-              </a:spcAft>
-            </a:pPr>
-            <a:r>
-              <a:rPr sz="1800" b="0">
-                <a:solidFill>
-                  <a:srgbClr val="1A1A1A"/>
-                </a:solidFill>
-                <a:latin typeface="Calibri"/>
-              </a:rPr>
-              <a:t>•  Tax, Hustler Fund terms, VAT thresholds...) — many sub-topics had only 1-2 supporting</a:t>
-            </a:r>
-          </a:p>
-          <a:p>
-            <a:pPr>
-              <a:spcAft>
-                <a:spcPts val="1400"/>
-              </a:spcAft>
-            </a:pPr>
-            <a:r>
-              <a:rPr sz="1800" b="0">
-                <a:solidFill>
-                  <a:srgbClr val="1A1A1A"/>
-                </a:solidFill>
-                <a:latin typeface="Calibri"/>
-              </a:rPr>
-              <a:t>•  examples each.</a:t>
-            </a:r>
-          </a:p>
-          <a:p>
-            <a:pPr>
-              <a:spcAft>
-                <a:spcPts val="1400"/>
-              </a:spcAft>
-            </a:pPr>
-            <a:r>
-              <a:rPr sz="1800" b="0">
-                <a:solidFill>
-                  <a:srgbClr val="1A1A1A"/>
-                </a:solidFill>
-                <a:latin typeface="Calibri"/>
-              </a:rPr>
-              <a:t>•  </a:t>
-            </a:r>
-          </a:p>
-          <a:p>
-            <a:pPr>
-              <a:spcAft>
-                <a:spcPts val="1400"/>
-              </a:spcAft>
-            </a:pPr>
-            <a:r>
-              <a:rPr sz="1800" b="0">
-                <a:solidFill>
-                  <a:srgbClr val="1A1A1A"/>
-                </a:solidFill>
-                <a:latin typeface="Calibri"/>
-              </a:rPr>
-              <a:t>•  Enough repetition to imprint fluent structure and tone. Not enough repetition to reliably</a:t>
-            </a:r>
-          </a:p>
-          <a:p>
-            <a:pPr>
-              <a:spcAft>
-                <a:spcPts val="1400"/>
-              </a:spcAft>
-            </a:pPr>
-            <a:r>
-              <a:rPr sz="1800" b="0">
-                <a:solidFill>
-                  <a:srgbClr val="1A1A1A"/>
-                </a:solidFill>
-                <a:latin typeface="Calibri"/>
-              </a:rPr>
-              <a:t>•  fix exact numbers on narrow questions.</a:t>
-            </a:r>
-          </a:p>
-          <a:p>
-            <a:pPr>
-              <a:spcAft>
-                <a:spcPts val="1400"/>
-              </a:spcAft>
-            </a:pPr>
-            <a:r>
-              <a:rPr sz="1800" b="0">
-                <a:solidFill>
-                  <a:srgbClr val="1A1A1A"/>
-                </a:solidFill>
-                <a:latin typeface="Calibri"/>
-              </a:rPr>
-              <a:t>•  </a:t>
-            </a:r>
-          </a:p>
-          <a:p>
-            <a:pPr>
-              <a:spcAft>
-                <a:spcPts val="1400"/>
-              </a:spcAft>
-            </a:pPr>
-            <a:r>
-              <a:rPr sz="1800" b="0">
-                <a:solidFill>
-                  <a:srgbClr val="1A1A1A"/>
-                </a:solidFill>
-                <a:latin typeface="Calibri"/>
-              </a:rPr>
-              <a:t>•  mobile_money / business_registration questions are more procedural ("follow these steps"),</a:t>
-            </a:r>
-          </a:p>
-          <a:p>
-            <a:pPr>
-              <a:spcAft>
-                <a:spcPts val="1400"/>
-              </a:spcAft>
-            </a:pPr>
-            <a:r>
-              <a:rPr sz="1800" b="0">
-                <a:solidFill>
-                  <a:srgbClr val="1A1A1A"/>
-                </a:solidFill>
-                <a:latin typeface="Calibri"/>
-              </a:rPr>
-              <a:t>•  which generalizes better from few examples than precise numeric facts do.</a:t>
+              <a:t>•  mobile_money / business_registration questions are more procedural ("follow these steps"), which generalizes better from few examples than precise numeric facts do.</a:t>
             </a:r>
           </a:p>
         </p:txBody>

</xml_diff>